<commit_message>
Prepare Rostrum 1.0 with layout docs and inspectable Lectern demos
</commit_message>
<xml_diff>
--- a/Lectern/Tests/LecternCoreTests/Fixtures/FeaturePipeline/authored-features.pptx
+++ b/Lectern/Tests/LecternCoreTests/Fixtures/FeaturePipeline/authored-features.pptx
@@ -1122,7 +1122,7 @@
                       </a:r>
                     </a:p>
                   </a:txBody>
-                  <a:tcPr>
+                  <a:tcPr anchor="ctr">
                     <a:lnB w="50800" cmpd="dbl">
                       <a:solidFill>
                         <a:srgbClr val="336699"/>
@@ -1141,7 +1141,7 @@
                       </a:r>
                     </a:p>
                   </a:txBody>
-                  <a:tcPr/>
+                  <a:tcPr anchor="ctr"/>
                 </a:tc>
                 <a:tc>
                   <a:txBody>
@@ -1153,7 +1153,7 @@
                       </a:r>
                     </a:p>
                   </a:txBody>
-                  <a:tcPr/>
+                  <a:tcPr anchor="ctr"/>
                 </a:tc>
               </a:tr>
               <a:tr h="914400">
@@ -1167,7 +1167,7 @@
                       </a:r>
                     </a:p>
                   </a:txBody>
-                  <a:tcPr>
+                  <a:tcPr anchor="ctr">
                     <a:lnB w="25400" cmpd="sng">
                       <a:solidFill>
                         <a:srgbClr val="336699"/>
@@ -1186,7 +1186,7 @@
                       </a:r>
                     </a:p>
                   </a:txBody>
-                  <a:tcPr/>
+                  <a:tcPr anchor="ctr"/>
                 </a:tc>
                 <a:tc>
                   <a:txBody>
@@ -1198,7 +1198,7 @@
                       </a:r>
                     </a:p>
                   </a:txBody>
-                  <a:tcPr/>
+                  <a:tcPr anchor="ctr"/>
                 </a:tc>
               </a:tr>
               <a:tr h="914400">
@@ -1212,7 +1212,7 @@
                       </a:r>
                     </a:p>
                   </a:txBody>
-                  <a:tcPr/>
+                  <a:tcPr anchor="ctr"/>
                 </a:tc>
                 <a:tc gridSpan="2">
                   <a:txBody>
@@ -1224,7 +1224,7 @@
                       </a:r>
                     </a:p>
                   </a:txBody>
-                  <a:tcPr/>
+                  <a:tcPr anchor="ctr"/>
                 </a:tc>
                 <a:tc hMerge="1">
                   <a:txBody>
@@ -1232,7 +1232,7 @@
                     <a:lstStyle/>
                     <a:p/>
                   </a:txBody>
-                  <a:tcPr/>
+                  <a:tcPr anchor="ctr"/>
                 </a:tc>
               </a:tr>
             </a:tbl>
@@ -1479,7 +1479,7 @@
                       </a:r>
                     </a:p>
                   </a:txBody>
-                  <a:tcPr/>
+                  <a:tcPr anchor="ctr"/>
                 </a:tc>
                 <a:tc>
                   <a:txBody>
@@ -1491,7 +1491,7 @@
                       </a:r>
                     </a:p>
                   </a:txBody>
-                  <a:tcPr/>
+                  <a:tcPr anchor="ctr"/>
                 </a:tc>
               </a:tr>
             </a:tbl>

</xml_diff>

<commit_message>
Match template soft breaks and title styles to PowerPoint
</commit_message>
<xml_diff>
--- a/Lectern/Tests/LecternCoreTests/Fixtures/FeaturePipeline/authored-features.pptx
+++ b/Lectern/Tests/LecternCoreTests/Fixtures/FeaturePipeline/authored-features.pptx
@@ -980,6 +980,149 @@
     <p:sldLayoutId id="2147483651" r:id="rId3"/>
     <p:sldLayoutId id="2147483652" r:id="rId4"/>
   </p:sldLayoutIdLst>
+  <p:txStyles>
+    <p:titleStyle>
+      <a:lvl1pPr>
+        <a:defRPr sz="4400" kern="0">
+          <a:latin typeface="+mj-lt"/>
+        </a:defRPr>
+      </a:lvl1pPr>
+      <a:lvl2pPr>
+        <a:defRPr sz="4400" kern="0">
+          <a:latin typeface="+mj-lt"/>
+        </a:defRPr>
+      </a:lvl2pPr>
+      <a:lvl3pPr>
+        <a:defRPr sz="4400" kern="0">
+          <a:latin typeface="+mj-lt"/>
+        </a:defRPr>
+      </a:lvl3pPr>
+      <a:lvl4pPr>
+        <a:defRPr sz="4400" kern="0">
+          <a:latin typeface="+mj-lt"/>
+        </a:defRPr>
+      </a:lvl4pPr>
+      <a:lvl5pPr>
+        <a:defRPr sz="4400" kern="0">
+          <a:latin typeface="+mj-lt"/>
+        </a:defRPr>
+      </a:lvl5pPr>
+      <a:lvl6pPr>
+        <a:defRPr sz="4400" kern="0">
+          <a:latin typeface="+mj-lt"/>
+        </a:defRPr>
+      </a:lvl6pPr>
+      <a:lvl7pPr>
+        <a:defRPr sz="4400" kern="0">
+          <a:latin typeface="+mj-lt"/>
+        </a:defRPr>
+      </a:lvl7pPr>
+      <a:lvl8pPr>
+        <a:defRPr sz="4400" kern="0">
+          <a:latin typeface="+mj-lt"/>
+        </a:defRPr>
+      </a:lvl8pPr>
+      <a:lvl9pPr>
+        <a:defRPr sz="4400" kern="0">
+          <a:latin typeface="+mj-lt"/>
+        </a:defRPr>
+      </a:lvl9pPr>
+    </p:titleStyle>
+    <p:bodyStyle>
+      <a:lvl1pPr>
+        <a:defRPr sz="1800" kern="0">
+          <a:latin typeface="+mn-lt"/>
+        </a:defRPr>
+      </a:lvl1pPr>
+      <a:lvl2pPr>
+        <a:defRPr sz="1800" kern="0">
+          <a:latin typeface="+mn-lt"/>
+        </a:defRPr>
+      </a:lvl2pPr>
+      <a:lvl3pPr>
+        <a:defRPr sz="1800" kern="0">
+          <a:latin typeface="+mn-lt"/>
+        </a:defRPr>
+      </a:lvl3pPr>
+      <a:lvl4pPr>
+        <a:defRPr sz="1800" kern="0">
+          <a:latin typeface="+mn-lt"/>
+        </a:defRPr>
+      </a:lvl4pPr>
+      <a:lvl5pPr>
+        <a:defRPr sz="1800" kern="0">
+          <a:latin typeface="+mn-lt"/>
+        </a:defRPr>
+      </a:lvl5pPr>
+      <a:lvl6pPr>
+        <a:defRPr sz="1800" kern="0">
+          <a:latin typeface="+mn-lt"/>
+        </a:defRPr>
+      </a:lvl6pPr>
+      <a:lvl7pPr>
+        <a:defRPr sz="1800" kern="0">
+          <a:latin typeface="+mn-lt"/>
+        </a:defRPr>
+      </a:lvl7pPr>
+      <a:lvl8pPr>
+        <a:defRPr sz="1800" kern="0">
+          <a:latin typeface="+mn-lt"/>
+        </a:defRPr>
+      </a:lvl8pPr>
+      <a:lvl9pPr>
+        <a:defRPr sz="1800" kern="0">
+          <a:latin typeface="+mn-lt"/>
+        </a:defRPr>
+      </a:lvl9pPr>
+    </p:bodyStyle>
+    <p:otherStyle>
+      <a:lvl1pPr>
+        <a:defRPr sz="1800" kern="0">
+          <a:latin typeface="+mn-lt"/>
+        </a:defRPr>
+      </a:lvl1pPr>
+      <a:lvl2pPr>
+        <a:defRPr sz="1800" kern="0">
+          <a:latin typeface="+mn-lt"/>
+        </a:defRPr>
+      </a:lvl2pPr>
+      <a:lvl3pPr>
+        <a:defRPr sz="1800" kern="0">
+          <a:latin typeface="+mn-lt"/>
+        </a:defRPr>
+      </a:lvl3pPr>
+      <a:lvl4pPr>
+        <a:defRPr sz="1800" kern="0">
+          <a:latin typeface="+mn-lt"/>
+        </a:defRPr>
+      </a:lvl4pPr>
+      <a:lvl5pPr>
+        <a:defRPr sz="1800" kern="0">
+          <a:latin typeface="+mn-lt"/>
+        </a:defRPr>
+      </a:lvl5pPr>
+      <a:lvl6pPr>
+        <a:defRPr sz="1800" kern="0">
+          <a:latin typeface="+mn-lt"/>
+        </a:defRPr>
+      </a:lvl6pPr>
+      <a:lvl7pPr>
+        <a:defRPr sz="1800" kern="0">
+          <a:latin typeface="+mn-lt"/>
+        </a:defRPr>
+      </a:lvl7pPr>
+      <a:lvl8pPr>
+        <a:defRPr sz="1800" kern="0">
+          <a:latin typeface="+mn-lt"/>
+        </a:defRPr>
+      </a:lvl8pPr>
+      <a:lvl9pPr>
+        <a:defRPr sz="1800" kern="0">
+          <a:latin typeface="+mn-lt"/>
+        </a:defRPr>
+      </a:lvl9pPr>
+    </p:otherStyle>
+  </p:txStyles>
 </p:sldMaster>
 </file>
 
@@ -1068,6 +1211,149 @@
     <p:sldLayoutId id="2147483655" r:id="rId3"/>
     <p:sldLayoutId id="2147483656" r:id="rId4"/>
   </p:sldLayoutIdLst>
+  <p:txStyles>
+    <p:titleStyle>
+      <a:lvl1pPr>
+        <a:defRPr kern="0" sz="4400">
+          <a:latin typeface="+mj-lt"/>
+        </a:defRPr>
+      </a:lvl1pPr>
+      <a:lvl2pPr>
+        <a:defRPr kern="0" sz="4400">
+          <a:latin typeface="+mj-lt"/>
+        </a:defRPr>
+      </a:lvl2pPr>
+      <a:lvl3pPr>
+        <a:defRPr kern="0" sz="4400">
+          <a:latin typeface="+mj-lt"/>
+        </a:defRPr>
+      </a:lvl3pPr>
+      <a:lvl4pPr>
+        <a:defRPr kern="0" sz="4400">
+          <a:latin typeface="+mj-lt"/>
+        </a:defRPr>
+      </a:lvl4pPr>
+      <a:lvl5pPr>
+        <a:defRPr kern="0" sz="4400">
+          <a:latin typeface="+mj-lt"/>
+        </a:defRPr>
+      </a:lvl5pPr>
+      <a:lvl6pPr>
+        <a:defRPr kern="0" sz="4400">
+          <a:latin typeface="+mj-lt"/>
+        </a:defRPr>
+      </a:lvl6pPr>
+      <a:lvl7pPr>
+        <a:defRPr kern="0" sz="4400">
+          <a:latin typeface="+mj-lt"/>
+        </a:defRPr>
+      </a:lvl7pPr>
+      <a:lvl8pPr>
+        <a:defRPr kern="0" sz="4400">
+          <a:latin typeface="+mj-lt"/>
+        </a:defRPr>
+      </a:lvl8pPr>
+      <a:lvl9pPr>
+        <a:defRPr kern="0" sz="4400">
+          <a:latin typeface="+mj-lt"/>
+        </a:defRPr>
+      </a:lvl9pPr>
+    </p:titleStyle>
+    <p:bodyStyle>
+      <a:lvl1pPr>
+        <a:defRPr kern="0" sz="1800">
+          <a:latin typeface="+mn-lt"/>
+        </a:defRPr>
+      </a:lvl1pPr>
+      <a:lvl2pPr>
+        <a:defRPr kern="0" sz="1800">
+          <a:latin typeface="+mn-lt"/>
+        </a:defRPr>
+      </a:lvl2pPr>
+      <a:lvl3pPr>
+        <a:defRPr kern="0" sz="1800">
+          <a:latin typeface="+mn-lt"/>
+        </a:defRPr>
+      </a:lvl3pPr>
+      <a:lvl4pPr>
+        <a:defRPr kern="0" sz="1800">
+          <a:latin typeface="+mn-lt"/>
+        </a:defRPr>
+      </a:lvl4pPr>
+      <a:lvl5pPr>
+        <a:defRPr kern="0" sz="1800">
+          <a:latin typeface="+mn-lt"/>
+        </a:defRPr>
+      </a:lvl5pPr>
+      <a:lvl6pPr>
+        <a:defRPr kern="0" sz="1800">
+          <a:latin typeface="+mn-lt"/>
+        </a:defRPr>
+      </a:lvl6pPr>
+      <a:lvl7pPr>
+        <a:defRPr kern="0" sz="1800">
+          <a:latin typeface="+mn-lt"/>
+        </a:defRPr>
+      </a:lvl7pPr>
+      <a:lvl8pPr>
+        <a:defRPr kern="0" sz="1800">
+          <a:latin typeface="+mn-lt"/>
+        </a:defRPr>
+      </a:lvl8pPr>
+      <a:lvl9pPr>
+        <a:defRPr kern="0" sz="1800">
+          <a:latin typeface="+mn-lt"/>
+        </a:defRPr>
+      </a:lvl9pPr>
+    </p:bodyStyle>
+    <p:otherStyle>
+      <a:lvl1pPr>
+        <a:defRPr kern="0" sz="1800">
+          <a:latin typeface="+mn-lt"/>
+        </a:defRPr>
+      </a:lvl1pPr>
+      <a:lvl2pPr>
+        <a:defRPr kern="0" sz="1800">
+          <a:latin typeface="+mn-lt"/>
+        </a:defRPr>
+      </a:lvl2pPr>
+      <a:lvl3pPr>
+        <a:defRPr kern="0" sz="1800">
+          <a:latin typeface="+mn-lt"/>
+        </a:defRPr>
+      </a:lvl3pPr>
+      <a:lvl4pPr>
+        <a:defRPr kern="0" sz="1800">
+          <a:latin typeface="+mn-lt"/>
+        </a:defRPr>
+      </a:lvl4pPr>
+      <a:lvl5pPr>
+        <a:defRPr kern="0" sz="1800">
+          <a:latin typeface="+mn-lt"/>
+        </a:defRPr>
+      </a:lvl5pPr>
+      <a:lvl6pPr>
+        <a:defRPr kern="0" sz="1800">
+          <a:latin typeface="+mn-lt"/>
+        </a:defRPr>
+      </a:lvl6pPr>
+      <a:lvl7pPr>
+        <a:defRPr kern="0" sz="1800">
+          <a:latin typeface="+mn-lt"/>
+        </a:defRPr>
+      </a:lvl7pPr>
+      <a:lvl8pPr>
+        <a:defRPr kern="0" sz="1800">
+          <a:latin typeface="+mn-lt"/>
+        </a:defRPr>
+      </a:lvl8pPr>
+      <a:lvl9pPr>
+        <a:defRPr kern="0" sz="1800">
+          <a:latin typeface="+mn-lt"/>
+        </a:defRPr>
+      </a:lvl9pPr>
+    </p:otherStyle>
+  </p:txStyles>
 </p:sldMaster>
 </file>
 

</xml_diff>